<commit_message>
feat: make Nirupam Raut and Bhudev Singh the only Head Admins
- add USR023 Nirupam Raut and USR024 Bhudev Singh (role Admin) to the seed data
  and the generator; USR001 is kept for the history but deactivated
- escalation fallback picks an active Head Admin
- tests, README, presentation guide and deck updated (16,760 documents)
</commit_message>
<xml_diff>
--- a/docs/ClaimSure_Project_Presentation.pptx
+++ b/docs/ClaimSure_Project_Presentation.pptx
@@ -143,7 +143,7 @@
   <p:extLst>
     <p:ext uri="{521415D9-36F7-43E2-AB2F-B90AF26B5E84}">
       <p14:sectionLst xmlns:p14="http://schemas.microsoft.com/office/powerpoint/2010/main">
-        <p14:section name="Problem and goals" id="{7670d28e-d3e5-284f-5008-49c213cc2d44}">
+        <p14:section name="Problem and goals" id="{cbf3242c-a61d-ed4b-7e0d-31ace3bf7f05}">
           <p14:sldIdLst>
             <p14:sldId id="256"/>
             <p14:sldId id="257"/>
@@ -152,14 +152,14 @@
             <p14:sldId id="260"/>
           </p14:sldIdLst>
         </p14:section>
-        <p14:section name="System and data" id="{71557cff-26a5-09a7-684e-5b94872ec9e4}">
+        <p14:section name="System and data" id="{5fb46923-afa2-bd3c-0ed6-7a7c8b860ca9}">
           <p14:sldIdLst>
             <p14:sldId id="261"/>
             <p14:sldId id="262"/>
             <p14:sldId id="263"/>
           </p14:sldIdLst>
         </p14:section>
-        <p14:section name="Schema design" id="{84529f86-907d-71da-7b08-91854cda9c86}">
+        <p14:section name="Schema design" id="{f6c9cccb-22ea-e962-8e93-39d49cf8a760}">
           <p14:sldIdLst>
             <p14:sldId id="264"/>
             <p14:sldId id="265"/>
@@ -167,7 +167,7 @@
             <p14:sldId id="267"/>
           </p14:sldIdLst>
         </p14:section>
-        <p14:section name="Claim processing" id="{bb5e239f-66f5-d546-5be9-f5cadce7ab1c}">
+        <p14:section name="Claim processing" id="{5c2f080b-f4c5-0fe7-ced7-03b8df1cc2d4}">
           <p14:sldIdLst>
             <p14:sldId id="268"/>
             <p14:sldId id="269"/>
@@ -177,7 +177,7 @@
             <p14:sldId id="273"/>
           </p14:sldIdLst>
         </p14:section>
-        <p14:section name="Optimisation and analytics" id="{9d8ab2b9-0210-d9db-6073-61fff26cc11a}">
+        <p14:section name="Optimisation and analytics" id="{ac17a0a7-0c20-56cd-ae0e-bef7cc68edfa}">
           <p14:sldIdLst>
             <p14:sldId id="274"/>
             <p14:sldId id="275"/>
@@ -189,7 +189,7 @@
             <p14:sldId id="281"/>
           </p14:sldIdLst>
         </p14:section>
-        <p14:section name="Administration and results" id="{8124ead7-2c40-e6a4-d4e9-e15ff888540c}">
+        <p14:section name="Administration and results" id="{0dd7a0b1-78f8-998a-c5e1-36408f38e2e4}">
           <p14:sldIdLst>
             <p14:sldId id="282"/>
             <p14:sldId id="283"/>
@@ -9550,7 +9550,7 @@
                   <a:schemeClr val="accent2"/>
                 </a:solidFill>
               </a:rPr>
-              <a:t>16,758</a:t>
+              <a:t>16,760</a:t>
             </a:r>
             <a:endParaRPr lang="en-US" sz="3600" dirty="0"/>
           </a:p>
@@ -42638,7 +42638,7 @@
                   <a:schemeClr val="accent1"/>
                 </a:solidFill>
               </a:rPr>
-              <a:t>16,758</a:t>
+              <a:t>16,760</a:t>
             </a:r>
             <a:endParaRPr lang="en-US" sz="2800" dirty="0"/>
           </a:p>
@@ -44438,7 +44438,7 @@
                   <a:schemeClr val="accent6"/>
                 </a:solidFill>
               </a:rPr>
-              <a:t>22 docs</a:t>
+              <a:t>24 docs</a:t>
             </a:r>
             <a:endParaRPr lang="en-US" sz="1100" dirty="0"/>
           </a:p>

</xml_diff>